<commit_message>
Completed data preprocessing with one-hot encoding and train-test split
</commit_message>
<xml_diff>
--- a/Presentations/Week1 & week2-project2pptx.pptx
+++ b/Presentations/Week1 & week2-project2pptx.pptx
@@ -114,6 +114,11 @@
       </a:defRPr>
     </a:lvl9pPr>
   </p:defaultTextStyle>
+  <p:extLst>
+    <p:ext uri="{EFAFB233-063F-42B5-8137-9DF3F51BA10A}">
+      <p15:sldGuideLst xmlns:p15="http://schemas.microsoft.com/office/powerpoint/2012/main"/>
+    </p:ext>
+  </p:extLst>
 </p:presentation>
 </file>
 
@@ -330,7 +335,7 @@
           <a:p>
             <a:fld id="{5804FCB3-1021-4AF3-96E0-D932172C1794}" type="datetimeFigureOut">
               <a:rPr lang="en-US" smtClean="0"/>
-              <a:t>6/25/2026</a:t>
+              <a:t>7/2/2026</a:t>
             </a:fld>
             <a:endParaRPr lang="en-US"/>
           </a:p>
@@ -621,7 +626,7 @@
           <a:p>
             <a:fld id="{5804FCB3-1021-4AF3-96E0-D932172C1794}" type="datetimeFigureOut">
               <a:rPr lang="en-US" smtClean="0"/>
-              <a:t>6/25/2026</a:t>
+              <a:t>7/2/2026</a:t>
             </a:fld>
             <a:endParaRPr lang="en-US"/>
           </a:p>
@@ -880,7 +885,7 @@
           <a:p>
             <a:fld id="{5804FCB3-1021-4AF3-96E0-D932172C1794}" type="datetimeFigureOut">
               <a:rPr lang="en-US" smtClean="0"/>
-              <a:t>6/25/2026</a:t>
+              <a:t>7/2/2026</a:t>
             </a:fld>
             <a:endParaRPr lang="en-US"/>
           </a:p>
@@ -1349,7 +1354,7 @@
           <a:p>
             <a:fld id="{5804FCB3-1021-4AF3-96E0-D932172C1794}" type="datetimeFigureOut">
               <a:rPr lang="en-US" smtClean="0"/>
-              <a:t>6/25/2026</a:t>
+              <a:t>7/2/2026</a:t>
             </a:fld>
             <a:endParaRPr lang="en-US"/>
           </a:p>
@@ -1529,7 +1534,7 @@
           <a:p>
             <a:fld id="{5804FCB3-1021-4AF3-96E0-D932172C1794}" type="datetimeFigureOut">
               <a:rPr lang="en-US" smtClean="0"/>
-              <a:t>6/25/2026</a:t>
+              <a:t>7/2/2026</a:t>
             </a:fld>
             <a:endParaRPr lang="en-US"/>
           </a:p>
@@ -2105,7 +2110,7 @@
           <a:p>
             <a:fld id="{5804FCB3-1021-4AF3-96E0-D932172C1794}" type="datetimeFigureOut">
               <a:rPr lang="en-US" smtClean="0"/>
-              <a:t>6/25/2026</a:t>
+              <a:t>7/2/2026</a:t>
             </a:fld>
             <a:endParaRPr lang="en-US"/>
           </a:p>
@@ -2437,7 +2442,7 @@
           <a:p>
             <a:fld id="{5804FCB3-1021-4AF3-96E0-D932172C1794}" type="datetimeFigureOut">
               <a:rPr lang="en-US" smtClean="0"/>
-              <a:t>6/25/2026</a:t>
+              <a:t>7/2/2026</a:t>
             </a:fld>
             <a:endParaRPr lang="en-US"/>
           </a:p>
@@ -2612,7 +2617,7 @@
           <a:p>
             <a:fld id="{5804FCB3-1021-4AF3-96E0-D932172C1794}" type="datetimeFigureOut">
               <a:rPr lang="en-US" smtClean="0"/>
-              <a:t>6/25/2026</a:t>
+              <a:t>7/2/2026</a:t>
             </a:fld>
             <a:endParaRPr lang="en-US"/>
           </a:p>
@@ -2792,7 +2797,7 @@
           <a:p>
             <a:fld id="{5804FCB3-1021-4AF3-96E0-D932172C1794}" type="datetimeFigureOut">
               <a:rPr lang="en-US" smtClean="0"/>
-              <a:t>6/25/2026</a:t>
+              <a:t>7/2/2026</a:t>
             </a:fld>
             <a:endParaRPr lang="en-US"/>
           </a:p>
@@ -2962,7 +2967,7 @@
           <a:p>
             <a:fld id="{5804FCB3-1021-4AF3-96E0-D932172C1794}" type="datetimeFigureOut">
               <a:rPr lang="en-US" smtClean="0"/>
-              <a:t>6/25/2026</a:t>
+              <a:t>7/2/2026</a:t>
             </a:fld>
             <a:endParaRPr lang="en-US"/>
           </a:p>
@@ -3219,7 +3224,7 @@
           <a:p>
             <a:fld id="{5804FCB3-1021-4AF3-96E0-D932172C1794}" type="datetimeFigureOut">
               <a:rPr lang="en-US" smtClean="0"/>
-              <a:t>6/25/2026</a:t>
+              <a:t>7/2/2026</a:t>
             </a:fld>
             <a:endParaRPr lang="en-US"/>
           </a:p>
@@ -3511,7 +3516,7 @@
           <a:p>
             <a:fld id="{5804FCB3-1021-4AF3-96E0-D932172C1794}" type="datetimeFigureOut">
               <a:rPr lang="en-US" smtClean="0"/>
-              <a:t>6/25/2026</a:t>
+              <a:t>7/2/2026</a:t>
             </a:fld>
             <a:endParaRPr lang="en-US"/>
           </a:p>
@@ -3941,7 +3946,7 @@
           <a:p>
             <a:fld id="{5804FCB3-1021-4AF3-96E0-D932172C1794}" type="datetimeFigureOut">
               <a:rPr lang="en-US" smtClean="0"/>
-              <a:t>6/25/2026</a:t>
+              <a:t>7/2/2026</a:t>
             </a:fld>
             <a:endParaRPr lang="en-US"/>
           </a:p>
@@ -4059,7 +4064,7 @@
           <a:p>
             <a:fld id="{5804FCB3-1021-4AF3-96E0-D932172C1794}" type="datetimeFigureOut">
               <a:rPr lang="en-US" smtClean="0"/>
-              <a:t>6/25/2026</a:t>
+              <a:t>7/2/2026</a:t>
             </a:fld>
             <a:endParaRPr lang="en-US"/>
           </a:p>
@@ -4154,7 +4159,7 @@
           <a:p>
             <a:fld id="{5804FCB3-1021-4AF3-96E0-D932172C1794}" type="datetimeFigureOut">
               <a:rPr lang="en-US" smtClean="0"/>
-              <a:t>6/25/2026</a:t>
+              <a:t>7/2/2026</a:t>
             </a:fld>
             <a:endParaRPr lang="en-US"/>
           </a:p>
@@ -4437,7 +4442,7 @@
           <a:p>
             <a:fld id="{5804FCB3-1021-4AF3-96E0-D932172C1794}" type="datetimeFigureOut">
               <a:rPr lang="en-US" smtClean="0"/>
-              <a:t>6/25/2026</a:t>
+              <a:t>7/2/2026</a:t>
             </a:fld>
             <a:endParaRPr lang="en-US"/>
           </a:p>
@@ -4728,7 +4733,7 @@
           <a:p>
             <a:fld id="{5804FCB3-1021-4AF3-96E0-D932172C1794}" type="datetimeFigureOut">
               <a:rPr lang="en-US" smtClean="0"/>
-              <a:t>6/25/2026</a:t>
+              <a:t>7/2/2026</a:t>
             </a:fld>
             <a:endParaRPr lang="en-US"/>
           </a:p>
@@ -4959,7 +4964,7 @@
           <a:p>
             <a:fld id="{5804FCB3-1021-4AF3-96E0-D932172C1794}" type="datetimeFigureOut">
               <a:rPr lang="en-US" smtClean="0"/>
-              <a:t>6/25/2026</a:t>
+              <a:t>7/2/2026</a:t>
             </a:fld>
             <a:endParaRPr lang="en-US"/>
           </a:p>

</xml_diff>